<commit_message>
P8 : ajout notebook Jupyter + mise à jour PPTX
</commit_message>
<xml_diff>
--- a/livrables/P8_Regression_Notebook.pptx
+++ b/livrables/P8_Regression_Notebook.pptx
@@ -1938,17 +1938,6 @@
             <a:pPr marL="0" indent="0">
               <a:buNone/>
             </a:pPr>
-            <a:r>
-              <a:rPr lang="en-US" sz="2400" dirty="0">
-                <a:solidFill>
-                  <a:srgbClr val="000000"/>
-                </a:solidFill>
-                <a:latin typeface="Calibri" pitchFamily="34" charset="0"/>
-                <a:ea typeface="Calibri" pitchFamily="34" charset="-122"/>
-                <a:cs typeface="Calibri" pitchFamily="34" charset="-120"/>
-              </a:rPr>
-              <a:t>📈</a:t>
-            </a:r>
             <a:endParaRPr lang="en-US" sz="2400" dirty="0"/>
           </a:p>
         </p:txBody>
@@ -2087,17 +2076,6 @@
             <a:pPr marL="0" indent="0">
               <a:buNone/>
             </a:pPr>
-            <a:r>
-              <a:rPr lang="en-US" sz="2400" dirty="0">
-                <a:solidFill>
-                  <a:srgbClr val="000000"/>
-                </a:solidFill>
-                <a:latin typeface="Calibri" pitchFamily="34" charset="0"/>
-                <a:ea typeface="Calibri" pitchFamily="34" charset="-122"/>
-                <a:cs typeface="Calibri" pitchFamily="34" charset="-120"/>
-              </a:rPr>
-              <a:t>🎯</a:t>
-            </a:r>
             <a:endParaRPr lang="en-US" sz="2400" dirty="0"/>
           </a:p>
         </p:txBody>
@@ -2236,17 +2214,6 @@
             <a:pPr marL="0" indent="0">
               <a:buNone/>
             </a:pPr>
-            <a:r>
-              <a:rPr lang="en-US" sz="2400" dirty="0">
-                <a:solidFill>
-                  <a:srgbClr val="000000"/>
-                </a:solidFill>
-                <a:latin typeface="Calibri" pitchFamily="34" charset="0"/>
-                <a:ea typeface="Calibri" pitchFamily="34" charset="-122"/>
-                <a:cs typeface="Calibri" pitchFamily="34" charset="-120"/>
-              </a:rPr>
-              <a:t>🔍</a:t>
-            </a:r>
             <a:endParaRPr lang="en-US" sz="2400" dirty="0"/>
           </a:p>
         </p:txBody>
@@ -8133,7 +8100,7 @@
                 <a:ea typeface="Calibri" pitchFamily="34" charset="-122"/>
                 <a:cs typeface="Calibri" pitchFamily="34" charset="-120"/>
               </a:rPr>
-              <a:t>⚠️ Limites à communiquer au client :</a:t>
+              <a:t> Limites à communiquer au client :</a:t>
             </a:r>
             <a:endParaRPr lang="en-US" sz="1200" dirty="0"/>
           </a:p>

</xml_diff>